<commit_message>
Apply review corrections to HbA1c event deck and newsletter
Co-Authored-By: Claude Opus 5.5 <noreply@anthropic.com>
Claude-Session: https://claude.ai/code/session_01YWYkxPvTHRLM1CPf7x5ftM
</commit_message>
<xml_diff>
--- a/deliverables/hba1c-event/ニュースレター_血糖値HbA1c意識調査.pptx
+++ b/deliverables/hba1c-event/ニュースレター_血糖値HbA1c意識調査.pptx
@@ -110,7 +110,7 @@
   <p:extLst>
     <p:ext uri="{521415D9-36F7-43E2-AB2F-B90AF26B5E84}">
       <p14:sectionLst xmlns:p14="http://schemas.microsoft.com/office/powerpoint/2010/main">
-        <p14:section name="ニュースレター" id="{61f1c3d1-26fc-46ab-85bb-d2fded1135cd}">
+        <p14:section name="ニュースレター" id="{46c9ae46-da6b-e52d-a5ee-b2ad036f6fa7}">
           <p14:sldIdLst>
             <p14:sldId id="256"/>
             <p14:sldId id="257"/>
@@ -186,7 +186,7 @@
             <c:bubble3D val="0"/>
             <c:spPr>
               <a:solidFill>
-                <a:srgbClr val="B7C6D6"/>
+                <a:srgbClr val="46688C"/>
               </a:solidFill>
               <a:ln w="19050" cap="flat">
                 <a:solidFill>
@@ -370,7 +370,7 @@
             <c:bubble3D val="0"/>
             <c:spPr>
               <a:solidFill>
-                <a:srgbClr val="F3C9D0"/>
+                <a:srgbClr val="46688C"/>
               </a:solidFill>
               <a:ln w="19050" cap="flat">
                 <a:solidFill>
@@ -387,7 +387,7 @@
             <c:bubble3D val="0"/>
             <c:spPr>
               <a:solidFill>
-                <a:srgbClr val="46688C"/>
+                <a:srgbClr val="C8102E"/>
               </a:solidFill>
               <a:ln w="19050" cap="flat">
                 <a:solidFill>
@@ -493,10 +493,10 @@
               <c:numCache>
                 <c:ptCount val="2"/>
                 <c:pt idx="0">
-                  <c:v>31.3</c:v>
+                  <c:v>68.7</c:v>
                 </c:pt>
                 <c:pt idx="1">
-                  <c:v>68.7</c:v>
+                  <c:v>31.3</c:v>
                 </c:pt>
               </c:numCache>
             </c:numRef>
@@ -1838,7 +1838,7 @@
             <c:bubble3D val="0"/>
             <c:spPr>
               <a:solidFill>
-                <a:srgbClr val="F3C9D0"/>
+                <a:srgbClr val="B7C6D6"/>
               </a:solidFill>
               <a:ln w="19050" cap="flat">
                 <a:solidFill>
@@ -1855,7 +1855,7 @@
             <c:bubble3D val="0"/>
             <c:spPr>
               <a:solidFill>
-                <a:srgbClr val="B7C6D6"/>
+                <a:srgbClr val="C8102E"/>
               </a:solidFill>
               <a:ln w="19050" cap="flat">
                 <a:solidFill>
@@ -1961,10 +1961,10 @@
               <c:numCache>
                 <c:ptCount val="2"/>
                 <c:pt idx="0">
-                  <c:v>29.2</c:v>
+                  <c:v>70.8</c:v>
                 </c:pt>
                 <c:pt idx="1">
-                  <c:v>70.8</c:v>
+                  <c:v>29.2</c:v>
                 </c:pt>
               </c:numCache>
             </c:numRef>
@@ -4207,7 +4207,7 @@
             <a:avLst/>
           </a:prstGeom>
           <a:solidFill>
-            <a:srgbClr val="B7C6D6"/>
+            <a:srgbClr val="46688C"/>
           </a:solidFill>
           <a:ln/>
         </p:spPr>
@@ -4445,7 +4445,7 @@
             <a:avLst/>
           </a:prstGeom>
           <a:solidFill>
-            <a:srgbClr val="F3C9D0"/>
+            <a:srgbClr val="C8102E"/>
           </a:solidFill>
           <a:ln/>
         </p:spPr>
@@ -7196,7 +7196,7 @@
             <a:r>
               <a:rPr lang="en-US" sz="1050" b="1" dirty="0">
                 <a:solidFill>
-                  <a:srgbClr val="4A4A4A"/>
+                  <a:srgbClr val="C8102E"/>
                 </a:solidFill>
               </a:rPr>
               <a:t>29.2%</a:t>
@@ -9320,8 +9320,8 @@
         </p:nvSpPr>
         <p:spPr>
           <a:xfrm>
-            <a:off x="5569844" y="4826807"/>
-            <a:ext cx="181732" cy="336173"/>
+            <a:off x="5549336" y="4904739"/>
+            <a:ext cx="202240" cy="258241"/>
           </a:xfrm>
           <a:prstGeom prst="line">
             <a:avLst/>
@@ -9337,7 +9337,29 @@
       </p:sp>
       <p:sp>
         <p:nvSpPr>
-          <p:cNvPr id="56" name="Text 53"/>
+          <p:cNvPr id="56" name="Shape 53"/>
+          <p:cNvSpPr/>
+          <p:nvPr/>
+        </p:nvSpPr>
+        <p:spPr>
+          <a:xfrm>
+            <a:off x="5467303" y="4802197"/>
+            <a:ext cx="125785" cy="103909"/>
+          </a:xfrm>
+          <a:prstGeom prst="ellipse">
+            <a:avLst/>
+          </a:prstGeom>
+          <a:ln w="12700">
+            <a:solidFill>
+              <a:srgbClr val="262626"/>
+            </a:solidFill>
+            <a:prstDash val="solid"/>
+          </a:ln>
+        </p:spPr>
+      </p:sp>
+      <p:sp>
+        <p:nvSpPr>
+          <p:cNvPr id="57" name="Text 54"/>
           <p:cNvSpPr txBox="1"/>
           <p:nvPr/>
         </p:nvSpPr>
@@ -9373,7 +9395,7 @@
       </p:sp>
       <p:sp>
         <p:nvSpPr>
-          <p:cNvPr id="57" name="Text 54"/>
+          <p:cNvPr id="58" name="Text 55"/>
           <p:cNvSpPr txBox="1"/>
           <p:nvPr/>
         </p:nvSpPr>
@@ -9429,7 +9451,7 @@
       </p:sp>
       <p:sp>
         <p:nvSpPr>
-          <p:cNvPr id="58" name="Text 55"/>
+          <p:cNvPr id="59" name="Text 56"/>
           <p:cNvSpPr txBox="1"/>
           <p:nvPr/>
         </p:nvSpPr>
@@ -9465,7 +9487,7 @@
       </p:sp>
       <p:sp>
         <p:nvSpPr>
-          <p:cNvPr id="59" name="Text 56"/>
+          <p:cNvPr id="60" name="Text 57"/>
           <p:cNvSpPr txBox="1"/>
           <p:nvPr/>
         </p:nvSpPr>
@@ -9507,7 +9529,7 @@
       </p:sp>
       <p:sp>
         <p:nvSpPr>
-          <p:cNvPr id="60" name="Text 57"/>
+          <p:cNvPr id="61" name="Text 58"/>
           <p:cNvSpPr txBox="1"/>
           <p:nvPr/>
         </p:nvSpPr>
@@ -9549,7 +9571,7 @@
       </p:sp>
       <p:sp>
         <p:nvSpPr>
-          <p:cNvPr id="61" name="Text 58"/>
+          <p:cNvPr id="62" name="Text 59"/>
           <p:cNvSpPr txBox="1"/>
           <p:nvPr/>
         </p:nvSpPr>
@@ -9591,7 +9613,7 @@
       </p:sp>
       <p:sp>
         <p:nvSpPr>
-          <p:cNvPr id="62" name="Text 59"/>
+          <p:cNvPr id="63" name="Text 60"/>
           <p:cNvSpPr txBox="1"/>
           <p:nvPr/>
         </p:nvSpPr>
@@ -9627,7 +9649,7 @@
       </p:sp>
       <p:sp>
         <p:nvSpPr>
-          <p:cNvPr id="63" name="Text 60"/>
+          <p:cNvPr id="64" name="Text 61"/>
           <p:cNvSpPr txBox="1"/>
           <p:nvPr/>
         </p:nvSpPr>
@@ -9663,7 +9685,7 @@
       </p:sp>
       <p:sp>
         <p:nvSpPr>
-          <p:cNvPr id="64" name="Text 61"/>
+          <p:cNvPr id="65" name="Text 62"/>
           <p:cNvSpPr txBox="1"/>
           <p:nvPr/>
         </p:nvSpPr>
@@ -9701,7 +9723,7 @@
       </p:sp>
       <p:sp>
         <p:nvSpPr>
-          <p:cNvPr id="65" name="Text 62"/>
+          <p:cNvPr id="66" name="Text 63"/>
           <p:cNvSpPr txBox="1"/>
           <p:nvPr/>
         </p:nvSpPr>
@@ -9737,7 +9759,7 @@
       </p:sp>
       <p:sp>
         <p:nvSpPr>
-          <p:cNvPr id="66" name="Text 63"/>
+          <p:cNvPr id="67" name="Text 64"/>
           <p:cNvSpPr txBox="1"/>
           <p:nvPr/>
         </p:nvSpPr>
@@ -9784,7 +9806,7 @@
       </p:sp>
       <p:sp>
         <p:nvSpPr>
-          <p:cNvPr id="67" name="Shape 64"/>
+          <p:cNvPr id="68" name="Shape 65"/>
           <p:cNvSpPr/>
           <p:nvPr/>
         </p:nvSpPr>
@@ -9806,7 +9828,7 @@
       </p:sp>
       <p:sp>
         <p:nvSpPr>
-          <p:cNvPr id="68" name="Text 65"/>
+          <p:cNvPr id="69" name="Text 66"/>
           <p:cNvSpPr txBox="1"/>
           <p:nvPr/>
         </p:nvSpPr>
@@ -9856,7 +9878,7 @@
       </p:sp>
       <p:sp>
         <p:nvSpPr>
-          <p:cNvPr id="69" name="Text 66"/>
+          <p:cNvPr id="70" name="Text 67"/>
           <p:cNvSpPr txBox="1"/>
           <p:nvPr/>
         </p:nvSpPr>
@@ -9892,7 +9914,7 @@
       </p:sp>
       <p:sp>
         <p:nvSpPr>
-          <p:cNvPr id="70" name="Shape 67"/>
+          <p:cNvPr id="71" name="Shape 68"/>
           <p:cNvSpPr/>
           <p:nvPr/>
         </p:nvSpPr>
@@ -9905,7 +9927,7 @@
             <a:avLst/>
           </a:prstGeom>
           <a:solidFill>
-            <a:srgbClr val="2F4A66"/>
+            <a:srgbClr val="9E0D25"/>
           </a:solidFill>
           <a:ln w="12700">
             <a:solidFill>
@@ -9917,7 +9939,7 @@
       </p:sp>
       <p:sp>
         <p:nvSpPr>
-          <p:cNvPr id="71" name="Text 68"/>
+          <p:cNvPr id="72" name="Text 69"/>
           <p:cNvSpPr txBox="1"/>
           <p:nvPr/>
         </p:nvSpPr>
@@ -9953,7 +9975,7 @@
       </p:sp>
       <p:sp>
         <p:nvSpPr>
-          <p:cNvPr id="72" name="Shape 69"/>
+          <p:cNvPr id="73" name="Shape 70"/>
           <p:cNvSpPr/>
           <p:nvPr/>
         </p:nvSpPr>
@@ -9966,7 +9988,7 @@
             <a:avLst/>
           </a:prstGeom>
           <a:solidFill>
-            <a:srgbClr val="46688C"/>
+            <a:srgbClr val="C8102E"/>
           </a:solidFill>
           <a:ln w="12700">
             <a:solidFill>
@@ -9978,7 +10000,7 @@
       </p:sp>
       <p:sp>
         <p:nvSpPr>
-          <p:cNvPr id="73" name="Text 70"/>
+          <p:cNvPr id="74" name="Text 71"/>
           <p:cNvSpPr txBox="1"/>
           <p:nvPr/>
         </p:nvSpPr>
@@ -10014,7 +10036,7 @@
       </p:sp>
       <p:sp>
         <p:nvSpPr>
-          <p:cNvPr id="74" name="Shape 71"/>
+          <p:cNvPr id="75" name="Shape 72"/>
           <p:cNvSpPr/>
           <p:nvPr/>
         </p:nvSpPr>
@@ -10027,7 +10049,7 @@
             <a:avLst/>
           </a:prstGeom>
           <a:solidFill>
-            <a:srgbClr val="D5DBE2"/>
+            <a:srgbClr val="D9D9D9"/>
           </a:solidFill>
           <a:ln w="12700">
             <a:solidFill>
@@ -10039,7 +10061,7 @@
       </p:sp>
       <p:sp>
         <p:nvSpPr>
-          <p:cNvPr id="75" name="Text 72"/>
+          <p:cNvPr id="76" name="Text 73"/>
           <p:cNvSpPr txBox="1"/>
           <p:nvPr/>
         </p:nvSpPr>
@@ -10075,7 +10097,7 @@
       </p:sp>
       <p:sp>
         <p:nvSpPr>
-          <p:cNvPr id="76" name="Shape 73"/>
+          <p:cNvPr id="77" name="Shape 74"/>
           <p:cNvSpPr/>
           <p:nvPr/>
         </p:nvSpPr>
@@ -10088,7 +10110,7 @@
             <a:avLst/>
           </a:prstGeom>
           <a:solidFill>
-            <a:srgbClr val="9AA4AF"/>
+            <a:srgbClr val="A6A6A6"/>
           </a:solidFill>
           <a:ln w="12700">
             <a:solidFill>
@@ -10100,7 +10122,7 @@
       </p:sp>
       <p:sp>
         <p:nvSpPr>
-          <p:cNvPr id="77" name="Shape 74"/>
+          <p:cNvPr id="78" name="Shape 75"/>
           <p:cNvSpPr/>
           <p:nvPr/>
         </p:nvSpPr>
@@ -10123,7 +10145,7 @@
       </p:sp>
       <p:sp>
         <p:nvSpPr>
-          <p:cNvPr id="78" name="Shape 75"/>
+          <p:cNvPr id="79" name="Shape 76"/>
           <p:cNvSpPr/>
           <p:nvPr/>
         </p:nvSpPr>
@@ -10146,7 +10168,7 @@
       </p:sp>
       <p:sp>
         <p:nvSpPr>
-          <p:cNvPr id="79" name="Shape 76"/>
+          <p:cNvPr id="80" name="Shape 77"/>
           <p:cNvSpPr/>
           <p:nvPr/>
         </p:nvSpPr>
@@ -10169,7 +10191,7 @@
       </p:sp>
       <p:sp>
         <p:nvSpPr>
-          <p:cNvPr id="80" name="Shape 77"/>
+          <p:cNvPr id="81" name="Shape 78"/>
           <p:cNvSpPr/>
           <p:nvPr/>
         </p:nvSpPr>
@@ -10182,14 +10204,14 @@
             <a:avLst/>
           </a:prstGeom>
           <a:solidFill>
-            <a:srgbClr val="2F4A66"/>
+            <a:srgbClr val="9E0D25"/>
           </a:solidFill>
           <a:ln/>
         </p:spPr>
       </p:sp>
       <p:sp>
         <p:nvSpPr>
-          <p:cNvPr id="81" name="Text 78"/>
+          <p:cNvPr id="82" name="Text 79"/>
           <p:cNvSpPr txBox="1"/>
           <p:nvPr/>
         </p:nvSpPr>
@@ -10225,7 +10247,7 @@
       </p:sp>
       <p:sp>
         <p:nvSpPr>
-          <p:cNvPr id="82" name="Shape 79"/>
+          <p:cNvPr id="83" name="Shape 80"/>
           <p:cNvSpPr/>
           <p:nvPr/>
         </p:nvSpPr>
@@ -10238,14 +10260,14 @@
             <a:avLst/>
           </a:prstGeom>
           <a:solidFill>
-            <a:srgbClr val="46688C"/>
+            <a:srgbClr val="C8102E"/>
           </a:solidFill>
           <a:ln/>
         </p:spPr>
       </p:sp>
       <p:sp>
         <p:nvSpPr>
-          <p:cNvPr id="83" name="Text 80"/>
+          <p:cNvPr id="84" name="Text 81"/>
           <p:cNvSpPr txBox="1"/>
           <p:nvPr/>
         </p:nvSpPr>
@@ -10281,7 +10303,7 @@
       </p:sp>
       <p:sp>
         <p:nvSpPr>
-          <p:cNvPr id="84" name="Shape 81"/>
+          <p:cNvPr id="85" name="Shape 82"/>
           <p:cNvSpPr/>
           <p:nvPr/>
         </p:nvSpPr>
@@ -10294,14 +10316,14 @@
             <a:avLst/>
           </a:prstGeom>
           <a:solidFill>
-            <a:srgbClr val="D5DBE2"/>
+            <a:srgbClr val="D9D9D9"/>
           </a:solidFill>
           <a:ln/>
         </p:spPr>
       </p:sp>
       <p:sp>
         <p:nvSpPr>
-          <p:cNvPr id="85" name="Text 82"/>
+          <p:cNvPr id="86" name="Text 83"/>
           <p:cNvSpPr txBox="1"/>
           <p:nvPr/>
         </p:nvSpPr>
@@ -10337,7 +10359,7 @@
       </p:sp>
       <p:sp>
         <p:nvSpPr>
-          <p:cNvPr id="86" name="Shape 83"/>
+          <p:cNvPr id="87" name="Shape 84"/>
           <p:cNvSpPr/>
           <p:nvPr/>
         </p:nvSpPr>
@@ -10350,14 +10372,14 @@
             <a:avLst/>
           </a:prstGeom>
           <a:solidFill>
-            <a:srgbClr val="9AA4AF"/>
+            <a:srgbClr val="A6A6A6"/>
           </a:solidFill>
           <a:ln/>
         </p:spPr>
       </p:sp>
       <p:sp>
         <p:nvSpPr>
-          <p:cNvPr id="87" name="Text 84"/>
+          <p:cNvPr id="88" name="Text 85"/>
           <p:cNvSpPr txBox="1"/>
           <p:nvPr/>
         </p:nvSpPr>
@@ -10393,7 +10415,7 @@
       </p:sp>
       <p:sp>
         <p:nvSpPr>
-          <p:cNvPr id="88" name="Text 85"/>
+          <p:cNvPr id="89" name="Text 86"/>
           <p:cNvSpPr txBox="1"/>
           <p:nvPr/>
         </p:nvSpPr>

</xml_diff>